<commit_message>
Add PDF deck and fix layout defects found in visual QA
LibreOffice cannot render in this sandbox, so the PDF is produced by
rendering an HTML twin of the deck through headless Chromium. That
also made real visual QA possible for the first time.

Inspecting the rendered slides found defects the geometric check
could not see: dead space inside four cards, a disconnected stat
block, and body text sitting on a decorative circle on the closing
slide. All fixed in both the HTML/PDF and the PPTX so the two stay
consistent.

Co-Authored-By: Claude Opus 5 <noreply@anthropic.com>
Claude-Session: https://claude.ai/code/session_01CQxR3XD63uEFzKZrYbE3E3
</commit_message>
<xml_diff>
--- a/clients/juhi-agarwal-nexther/neXtHer-Proposal.pptx
+++ b/clients/juhi-agarwal-nexther/neXtHer-Proposal.pptx
@@ -2914,11 +2914,11 @@
         <p:spPr>
           <a:xfrm>
             <a:off x="640080" y="2148840"/>
-            <a:ext cx="3383280" cy="3657600"/>
+            <a:ext cx="3383280" cy="3154680"/>
           </a:xfrm>
           <a:prstGeom prst="roundRect">
             <a:avLst>
-              <a:gd name="adj" fmla="val 3784"/>
+              <a:gd name="adj" fmla="val 4058"/>
             </a:avLst>
           </a:prstGeom>
           <a:solidFill>
@@ -3225,11 +3225,11 @@
         <p:spPr>
           <a:xfrm>
             <a:off x="4389120" y="2148840"/>
-            <a:ext cx="3383280" cy="3657600"/>
+            <a:ext cx="3383280" cy="3154680"/>
           </a:xfrm>
           <a:prstGeom prst="roundRect">
             <a:avLst>
-              <a:gd name="adj" fmla="val 3784"/>
+              <a:gd name="adj" fmla="val 4058"/>
             </a:avLst>
           </a:prstGeom>
           <a:solidFill>
@@ -3536,11 +3536,11 @@
         <p:spPr>
           <a:xfrm>
             <a:off x="8138160" y="2148840"/>
-            <a:ext cx="3383280" cy="3657600"/>
+            <a:ext cx="3383280" cy="3154680"/>
           </a:xfrm>
           <a:prstGeom prst="roundRect">
             <a:avLst>
-              <a:gd name="adj" fmla="val 3784"/>
+              <a:gd name="adj" fmla="val 4058"/>
             </a:avLst>
           </a:prstGeom>
           <a:solidFill>
@@ -6914,8 +6914,8 @@
         </p:nvSpPr>
         <p:spPr>
           <a:xfrm>
-            <a:off x="-1554480" y="4206240"/>
-            <a:ext cx="4206240" cy="4206240"/>
+            <a:off x="-2651760" y="5669280"/>
+            <a:ext cx="3657600" cy="3657600"/>
           </a:xfrm>
           <a:prstGeom prst="ellipse">
             <a:avLst/>
@@ -7348,11 +7348,11 @@
         <p:spPr>
           <a:xfrm>
             <a:off x="8321040" y="1874520"/>
-            <a:ext cx="3200400" cy="2286000"/>
+            <a:ext cx="3200400" cy="1783080"/>
           </a:xfrm>
           <a:prstGeom prst="roundRect">
             <a:avLst>
-              <a:gd name="adj" fmla="val 5600"/>
+              <a:gd name="adj" fmla="val 7179"/>
             </a:avLst>
           </a:prstGeom>
           <a:solidFill>
@@ -8639,11 +8639,11 @@
         <p:spPr>
           <a:xfrm>
             <a:off x="640080" y="2103120"/>
-            <a:ext cx="4114800" cy="3200400"/>
+            <a:ext cx="4114800" cy="2834640"/>
           </a:xfrm>
           <a:prstGeom prst="roundRect">
             <a:avLst>
-              <a:gd name="adj" fmla="val 4000"/>
+              <a:gd name="adj" fmla="val 4516"/>
             </a:avLst>
           </a:prstGeom>
           <a:solidFill>
@@ -8959,7 +8959,7 @@
         </p:nvSpPr>
         <p:spPr>
           <a:xfrm>
-            <a:off x="5074920" y="3337560"/>
+            <a:off x="5074920" y="3538728"/>
             <a:ext cx="457200" cy="457200"/>
           </a:xfrm>
           <a:prstGeom prst="ellipse">
@@ -8979,7 +8979,7 @@
         </p:nvSpPr>
         <p:spPr>
           <a:xfrm>
-            <a:off x="5074920" y="3337560"/>
+            <a:off x="5074920" y="3538728"/>
             <a:ext cx="457200" cy="457200"/>
           </a:xfrm>
           <a:prstGeom prst="rect">
@@ -9018,7 +9018,7 @@
         </p:nvSpPr>
         <p:spPr>
           <a:xfrm>
-            <a:off x="5760720" y="3300984"/>
+            <a:off x="5760720" y="3502152"/>
             <a:ext cx="5760720" cy="320040"/>
           </a:xfrm>
           <a:prstGeom prst="rect">
@@ -9057,7 +9057,7 @@
         </p:nvSpPr>
         <p:spPr>
           <a:xfrm>
-            <a:off x="5760720" y="3648456"/>
+            <a:off x="5760720" y="3849624"/>
             <a:ext cx="5760720" cy="640080"/>
           </a:xfrm>
           <a:prstGeom prst="rect">
@@ -9099,7 +9099,7 @@
         </p:nvSpPr>
         <p:spPr>
           <a:xfrm>
-            <a:off x="5074920" y="4434840"/>
+            <a:off x="5074920" y="4837176"/>
             <a:ext cx="457200" cy="457200"/>
           </a:xfrm>
           <a:prstGeom prst="ellipse">
@@ -9119,7 +9119,7 @@
         </p:nvSpPr>
         <p:spPr>
           <a:xfrm>
-            <a:off x="5074920" y="4434840"/>
+            <a:off x="5074920" y="4837176"/>
             <a:ext cx="457200" cy="457200"/>
           </a:xfrm>
           <a:prstGeom prst="rect">
@@ -9158,7 +9158,7 @@
         </p:nvSpPr>
         <p:spPr>
           <a:xfrm>
-            <a:off x="5760720" y="4398264"/>
+            <a:off x="5760720" y="4800600"/>
             <a:ext cx="5760720" cy="320040"/>
           </a:xfrm>
           <a:prstGeom prst="rect">
@@ -9197,7 +9197,7 @@
         </p:nvSpPr>
         <p:spPr>
           <a:xfrm>
-            <a:off x="5760720" y="4745736"/>
+            <a:off x="5760720" y="5148072"/>
             <a:ext cx="5760720" cy="640080"/>
           </a:xfrm>
           <a:prstGeom prst="rect">
@@ -10252,24 +10252,24 @@
         </p:nvSpPr>
         <p:spPr>
           <a:xfrm>
-            <a:off x="640080" y="1463040"/>
-            <a:ext cx="3657600" cy="1554480"/>
-          </a:xfrm>
-          <a:prstGeom prst="rect">
-            <a:avLst/>
-          </a:prstGeom>
-          <a:noFill/>
-          <a:ln/>
-        </p:spPr>
-        <p:txBody>
-          <a:bodyPr wrap="square" lIns="0" tIns="0" rIns="0" bIns="0" rtlCol="0" anchor="ctr"/>
-          <a:lstStyle/>
-          <a:p>
-            <a:pPr indent="0" marL="0">
-              <a:buNone/>
-            </a:pPr>
-            <a:r>
-              <a:rPr lang="en-US" sz="9600" b="1" dirty="0">
+            <a:off x="640080" y="1508760"/>
+            <a:ext cx="3657600" cy="1188720"/>
+          </a:xfrm>
+          <a:prstGeom prst="rect">
+            <a:avLst/>
+          </a:prstGeom>
+          <a:noFill/>
+          <a:ln/>
+        </p:spPr>
+        <p:txBody>
+          <a:bodyPr wrap="square" lIns="0" tIns="0" rIns="0" bIns="0" rtlCol="0" anchor="ctr"/>
+          <a:lstStyle/>
+          <a:p>
+            <a:pPr indent="0" marL="0">
+              <a:buNone/>
+            </a:pPr>
+            <a:r>
+              <a:rPr lang="en-US" sz="10500" b="1" dirty="0">
                 <a:solidFill>
                   <a:srgbClr val="D9A441"/>
                 </a:solidFill>
@@ -10279,7 +10279,7 @@
               </a:rPr>
               <a:t>34</a:t>
             </a:r>
-            <a:endParaRPr lang="en-US" sz="9600" dirty="0"/>
+            <a:endParaRPr lang="en-US" sz="10500" dirty="0"/>
           </a:p>
         </p:txBody>
       </p:sp>
@@ -10291,7 +10291,7 @@
         </p:nvSpPr>
         <p:spPr>
           <a:xfrm>
-            <a:off x="640080" y="2971800"/>
+            <a:off x="640080" y="2743200"/>
             <a:ext cx="4572000" cy="365760"/>
           </a:xfrm>
           <a:prstGeom prst="rect">
@@ -11178,11 +11178,11 @@
         <p:spPr>
           <a:xfrm>
             <a:off x="8503920" y="731520"/>
-            <a:ext cx="3017520" cy="1371600"/>
+            <a:ext cx="3017520" cy="1097280"/>
           </a:xfrm>
           <a:prstGeom prst="roundRect">
             <a:avLst>
-              <a:gd name="adj" fmla="val 9333"/>
+              <a:gd name="adj" fmla="val 11667"/>
             </a:avLst>
           </a:prstGeom>
           <a:solidFill>

</xml_diff>